<commit_message>
intent/kinneret-talk-deck: review fixes on 142708e - mixed Wade Storm step, neutral timeline, close headline, agentic, share line
- Timeline: the Wade Storm step carries cause_mix "data + model" (ledger) and a half-and-half dot;
  retitled "What moved the score"; notes drop "most from data".
- hook notes: this year is teal. olympics headline: "did no better than average".
- lesson explains "agentic"; share has its "this applies to you" line; Q&A: why one week.
- close: chart:close, the hook's graph under "Better data, not bigger models", QR top right.
- build_deck: stops with a plain message when talk.pdf is open in a viewer.
- talk.pdf not rebuilt in this commit: it is open in a viewer.

Co-Authored-By: Claude Opus 5.5 <noreply@anthropic.com>
Claude-Session: https://claude.ai/code/session_0193nCV9LSRkjivJfTxWrDYe
</commit_message>
<xml_diff>
--- a/docs/talk/talk.pptx
+++ b/docs/talk/talk.pptx
@@ -753,7 +753,7 @@
           </a:p>
           <a:p>
             <a:r>
-              <a:t>But you have to learn when to ride the agentic flow, and when to take it into your own hands, or it drifts. What decided which changes stayed was measurement, not trust.</a:t>
+              <a:t>But you have to learn when to ride the agentic flow, letting the AI run the work step after step on its own, and when to take it into your own hands, or it drifts. What decided which changes stayed was measurement, not trust.</a:t>
             </a:r>
           </a:p>
           <a:p>
@@ -913,7 +913,7 @@
           </a:p>
           <a:p>
             <a:r>
-              <a:t>The teal steps are data. Most of the movement came from data, not from the model. On our freeze it scores 0.76.</a:t>
+              <a:t>That was the biggest step by far, and it was both: a data fix and six model changes, together. After it the moves were small, and mostly data. On our freeze it scores 0.76.</a:t>
             </a:r>
           </a:p>
         </p:txBody>
@@ -1388,7 +1388,7 @@
           <a:lstStyle/>
           <a:p>
             <a:r>
-              <a:t>Here is every year since twenty twenty, laid on top of each other. The red one is this year. It's the lowest line on the chart, and it's still going down.</a:t>
+              <a:t>Here is every year since twenty twenty, laid on top of each other. The teal one is this year. It's the lowest line on the chart, and it's still going down.</a:t>
             </a:r>
           </a:p>
           <a:p>
@@ -1479,6 +1479,11 @@
           <a:p>
             <a:r>
               <a:t>Third, and most critical: human consumption. Pumping and abstraction from the lake. That data wasn't available to me at all. The human hand on the water balance is invisible to my model.</a:t>
+            </a:r>
+          </a:p>
+          <a:p>
+            <a:r>
+              <a:t>This applies to you: if you hold data like this, share it.</a:t>
             </a:r>
           </a:p>
           <a:p>
@@ -6688,7 +6693,7 @@
       <p:grpSpPr/>
       <p:pic>
         <p:nvPicPr>
-          <p:cNvPr id="2" name="Picture 1" descr="hook.png"/>
+          <p:cNvPr id="2" name="Picture 1" descr="close.png"/>
           <p:cNvPicPr>
             <a:picLocks noChangeAspect="1"/>
           </p:cNvPicPr>
@@ -6726,7 +6731,7 @@
         </p:blipFill>
         <p:spPr>
           <a:xfrm>
-            <a:off x="10591495" y="5257800"/>
+            <a:off x="10591495" y="274320"/>
             <a:ext cx="1325880" cy="1325880"/>
           </a:xfrm>
           <a:prstGeom prst="rect">

</xml_diff>

<commit_message>
intent/kinneret-talk-deck: one font family - Segoe UI Semibold headlines, Semilight body
The originator asked for a better font for the whole deck, like the lake
animation's month label but bolder. Slides and charts now use Segoe UI at
weights heavier than Light (Semibold 600, Semilight 350), the same pair as
the animation. The A9 font check matches the new names; the timeline's
"both" legend label moved clear of its dot. talk.pdf still to rebuild (open
in a PDF viewer).

Co-Authored-By: Claude Opus 5.5 <noreply@anthropic.com>
Claude-Session: https://claude.ai/code/session_0193nCV9LSRkjivJfTxWrDYe
</commit_message>
<xml_diff>
--- a/docs/talk/talk.pptx
+++ b/docs/talk/talk.pptx
@@ -5275,11 +5275,11 @@
           <a:p>
             <a:pPr algn="l"/>
             <a:r>
-              <a:rPr sz="4800" b="1">
+              <a:rPr sz="4800" b="0">
                 <a:solidFill>
                   <a:srgbClr val="1D1D1B"/>
                 </a:solidFill>
-                <a:latin typeface="Georgia"/>
+                <a:latin typeface="Segoe UI Semibold"/>
               </a:rPr>
               <a:t>Better data, not bigger models</a:t>
             </a:r>
@@ -5314,7 +5314,7 @@
                 <a:solidFill>
                   <a:srgbClr val="5F5D57"/>
                 </a:solidFill>
-                <a:latin typeface="Segoe UI"/>
+                <a:latin typeface="Segoe UI Semilight"/>
               </a:rPr>
               <a:t>Yonatan Most · Adnan Agbaria</a:t>
             </a:r>
@@ -5418,7 +5418,7 @@
                 <a:solidFill>
                   <a:srgbClr val="5F5D57"/>
                 </a:solidFill>
-                <a:latin typeface="Segoe UI"/>
+                <a:latin typeface="Segoe UI Semilight"/>
               </a:rPr>
               <a:t>picture to make by hand:</a:t>
             </a:r>
@@ -5430,7 +5430,7 @@
                 <a:solidFill>
                   <a:srgbClr val="5F5D57"/>
                 </a:solidFill>
-                <a:latin typeface="Segoe UI"/>
+                <a:latin typeface="Segoe UI Semilight"/>
               </a:rPr>
               <a:t>persona.png</a:t>
             </a:r>
@@ -5442,7 +5442,7 @@
                 <a:solidFill>
                   <a:srgbClr val="5F5D57"/>
                 </a:solidFill>
-                <a:latin typeface="Segoe UI"/>
+                <a:latin typeface="Segoe UI Semilight"/>
               </a:rPr>
               <a:t>(prompt in images/persona.prompt.txt)</a:t>
             </a:r>
@@ -5473,11 +5473,11 @@
           <a:p>
             <a:pPr algn="l"/>
             <a:r>
-              <a:rPr sz="3600" b="1">
+              <a:rPr sz="3600" b="0">
                 <a:solidFill>
                   <a:srgbClr val="1D1D1B"/>
                 </a:solidFill>
-                <a:latin typeface="Georgia"/>
+                <a:latin typeface="Segoe UI Semibold"/>
               </a:rPr>
               <a:t>The newest oldest trick in the book</a:t>
             </a:r>
@@ -5581,7 +5581,7 @@
                 <a:solidFill>
                   <a:srgbClr val="5F5D57"/>
                 </a:solidFill>
-                <a:latin typeface="Segoe UI"/>
+                <a:latin typeface="Segoe UI Semilight"/>
               </a:rPr>
               <a:t>picture to make by hand:</a:t>
             </a:r>
@@ -5593,7 +5593,7 @@
                 <a:solidFill>
                   <a:srgbClr val="5F5D57"/>
                 </a:solidFill>
-                <a:latin typeface="Segoe UI"/>
+                <a:latin typeface="Segoe UI Semilight"/>
               </a:rPr>
               <a:t>rain.png</a:t>
             </a:r>
@@ -5605,7 +5605,7 @@
                 <a:solidFill>
                   <a:srgbClr val="5F5D57"/>
                 </a:solidFill>
-                <a:latin typeface="Segoe UI"/>
+                <a:latin typeface="Segoe UI Semilight"/>
               </a:rPr>
               <a:t>(prompt in images/rain.prompt.txt)</a:t>
             </a:r>
@@ -5709,7 +5709,7 @@
                 <a:solidFill>
                   <a:srgbClr val="5F5D57"/>
                 </a:solidFill>
-                <a:latin typeface="Segoe UI"/>
+                <a:latin typeface="Segoe UI Semilight"/>
               </a:rPr>
               <a:t>picture to make by hand:</a:t>
             </a:r>
@@ -5721,7 +5721,7 @@
                 <a:solidFill>
                   <a:srgbClr val="5F5D57"/>
                 </a:solidFill>
-                <a:latin typeface="Segoe UI"/>
+                <a:latin typeface="Segoe UI Semilight"/>
               </a:rPr>
               <a:t>lesson.png</a:t>
             </a:r>
@@ -5733,7 +5733,7 @@
                 <a:solidFill>
                   <a:srgbClr val="5F5D57"/>
                 </a:solidFill>
-                <a:latin typeface="Segoe UI"/>
+                <a:latin typeface="Segoe UI Semilight"/>
               </a:rPr>
               <a:t>(prompt in images/lesson.prompt.txt)</a:t>
             </a:r>
@@ -5764,11 +5764,11 @@
           <a:p>
             <a:pPr algn="l"/>
             <a:r>
-              <a:rPr sz="3600" b="1">
+              <a:rPr sz="3600" b="0">
                 <a:solidFill>
                   <a:srgbClr val="1D1D1B"/>
                 </a:solidFill>
-                <a:latin typeface="Georgia"/>
+                <a:latin typeface="Segoe UI Semibold"/>
               </a:rPr>
               <a:t>Ride the flow, or take the wheel</a:t>
             </a:r>
@@ -6022,7 +6022,7 @@
                 <a:solidFill>
                   <a:srgbClr val="5F5D57"/>
                 </a:solidFill>
-                <a:latin typeface="Segoe UI"/>
+                <a:latin typeface="Segoe UI Semilight"/>
               </a:rPr>
               <a:t>picture to make by hand:</a:t>
             </a:r>
@@ -6034,7 +6034,7 @@
                 <a:solidFill>
                   <a:srgbClr val="5F5D57"/>
                 </a:solidFill>
-                <a:latin typeface="Segoe UI"/>
+                <a:latin typeface="Segoe UI Semilight"/>
               </a:rPr>
               <a:t>push.png</a:t>
             </a:r>
@@ -6046,7 +6046,7 @@
                 <a:solidFill>
                   <a:srgbClr val="5F5D57"/>
                 </a:solidFill>
-                <a:latin typeface="Segoe UI"/>
+                <a:latin typeface="Segoe UI Semilight"/>
               </a:rPr>
               <a:t>(prompt in images/push.prompt.txt)</a:t>
             </a:r>
@@ -6200,7 +6200,7 @@
                 <a:solidFill>
                   <a:srgbClr val="5F5D57"/>
                 </a:solidFill>
-                <a:latin typeface="Segoe UI"/>
+                <a:latin typeface="Segoe UI Semilight"/>
               </a:rPr>
               <a:t>picture to make by hand:</a:t>
             </a:r>
@@ -6212,7 +6212,7 @@
                 <a:solidFill>
                   <a:srgbClr val="5F5D57"/>
                 </a:solidFill>
-                <a:latin typeface="Segoe UI"/>
+                <a:latin typeface="Segoe UI Semilight"/>
               </a:rPr>
               <a:t>silent.png</a:t>
             </a:r>
@@ -6224,7 +6224,7 @@
                 <a:solidFill>
                   <a:srgbClr val="5F5D57"/>
                 </a:solidFill>
-                <a:latin typeface="Segoe UI"/>
+                <a:latin typeface="Segoe UI Semilight"/>
               </a:rPr>
               <a:t>(prompt in images/silent.prompt.txt)</a:t>
             </a:r>
@@ -6328,7 +6328,7 @@
                 <a:solidFill>
                   <a:srgbClr val="5F5D57"/>
                 </a:solidFill>
-                <a:latin typeface="Segoe UI"/>
+                <a:latin typeface="Segoe UI Semilight"/>
               </a:rPr>
               <a:t>picture to make by hand:</a:t>
             </a:r>
@@ -6340,7 +6340,7 @@
                 <a:solidFill>
                   <a:srgbClr val="5F5D57"/>
                 </a:solidFill>
-                <a:latin typeface="Segoe UI"/>
+                <a:latin typeface="Segoe UI Semilight"/>
               </a:rPr>
               <a:t>sensors.png</a:t>
             </a:r>
@@ -6352,7 +6352,7 @@
                 <a:solidFill>
                   <a:srgbClr val="5F5D57"/>
                 </a:solidFill>
-                <a:latin typeface="Segoe UI"/>
+                <a:latin typeface="Segoe UI Semilight"/>
               </a:rPr>
               <a:t>(prompt in images/sensors.prompt.txt)</a:t>
             </a:r>
@@ -6506,7 +6506,7 @@
                 <a:solidFill>
                   <a:srgbClr val="5F5D57"/>
                 </a:solidFill>
-                <a:latin typeface="Segoe UI"/>
+                <a:latin typeface="Segoe UI Semilight"/>
               </a:rPr>
               <a:t>picture to make by hand:</a:t>
             </a:r>
@@ -6518,7 +6518,7 @@
                 <a:solidFill>
                   <a:srgbClr val="5F5D57"/>
                 </a:solidFill>
-                <a:latin typeface="Segoe UI"/>
+                <a:latin typeface="Segoe UI Semilight"/>
               </a:rPr>
               <a:t>share.png</a:t>
             </a:r>
@@ -6530,7 +6530,7 @@
                 <a:solidFill>
                   <a:srgbClr val="5F5D57"/>
                 </a:solidFill>
-                <a:latin typeface="Segoe UI"/>
+                <a:latin typeface="Segoe UI Semilight"/>
               </a:rPr>
               <a:t>(prompt in images/share.prompt.txt)</a:t>
             </a:r>
@@ -6634,7 +6634,7 @@
                 <a:solidFill>
                   <a:srgbClr val="5F5D57"/>
                 </a:solidFill>
-                <a:latin typeface="Segoe UI"/>
+                <a:latin typeface="Segoe UI Semilight"/>
               </a:rPr>
               <a:t>picture to make by hand:</a:t>
             </a:r>
@@ -6646,7 +6646,7 @@
                 <a:solidFill>
                   <a:srgbClr val="5F5D57"/>
                 </a:solidFill>
-                <a:latin typeface="Segoe UI"/>
+                <a:latin typeface="Segoe UI Semilight"/>
               </a:rPr>
               <a:t>brain.png</a:t>
             </a:r>
@@ -6658,7 +6658,7 @@
                 <a:solidFill>
                   <a:srgbClr val="5F5D57"/>
                 </a:solidFill>
-                <a:latin typeface="Segoe UI"/>
+                <a:latin typeface="Segoe UI Semilight"/>
               </a:rPr>
               <a:t>(prompt in images/brain.prompt.txt)</a:t>
             </a:r>
@@ -6864,11 +6864,11 @@
           <a:p>
             <a:pPr algn="l"/>
             <a:r>
-              <a:rPr sz="4000" b="1">
+              <a:rPr sz="4000" b="0">
                 <a:solidFill>
                   <a:srgbClr val="1D1D1B"/>
                 </a:solidFill>
-                <a:latin typeface="Georgia"/>
+                <a:latin typeface="Segoe UI Semibold"/>
               </a:rPr>
               <a:t>Yonatan Most</a:t>
             </a:r>
@@ -6876,11 +6876,11 @@
           <a:p>
             <a:pPr algn="l"/>
             <a:r>
-              <a:rPr sz="4000" b="1">
+              <a:rPr sz="4000" b="0">
                 <a:solidFill>
                   <a:srgbClr val="1D1D1B"/>
                 </a:solidFill>
-                <a:latin typeface="Georgia"/>
+                <a:latin typeface="Segoe UI Semibold"/>
               </a:rPr>
               <a:t>Adnan Agbaria</a:t>
             </a:r>
@@ -6984,7 +6984,7 @@
                 <a:solidFill>
                   <a:srgbClr val="5F5D57"/>
                 </a:solidFill>
-                <a:latin typeface="Segoe UI"/>
+                <a:latin typeface="Segoe UI Semilight"/>
               </a:rPr>
               <a:t>picture to make by hand:</a:t>
             </a:r>
@@ -6996,7 +6996,7 @@
                 <a:solidFill>
                   <a:srgbClr val="5F5D57"/>
                 </a:solidFill>
-                <a:latin typeface="Segoe UI"/>
+                <a:latin typeface="Segoe UI Semilight"/>
               </a:rPr>
               <a:t>week.png</a:t>
             </a:r>
@@ -7008,7 +7008,7 @@
                 <a:solidFill>
                   <a:srgbClr val="5F5D57"/>
                 </a:solidFill>
-                <a:latin typeface="Segoe UI"/>
+                <a:latin typeface="Segoe UI Semilight"/>
               </a:rPr>
               <a:t>(prompt in images/week.prompt.txt)</a:t>
             </a:r>
@@ -7112,7 +7112,7 @@
                 <a:solidFill>
                   <a:srgbClr val="5F5D57"/>
                 </a:solidFill>
-                <a:latin typeface="Segoe UI"/>
+                <a:latin typeface="Segoe UI Semilight"/>
               </a:rPr>
               <a:t>picture to make by hand:</a:t>
             </a:r>
@@ -7124,7 +7124,7 @@
                 <a:solidFill>
                   <a:srgbClr val="5F5D57"/>
                 </a:solidFill>
-                <a:latin typeface="Segoe UI"/>
+                <a:latin typeface="Segoe UI Semilight"/>
               </a:rPr>
               <a:t>sources.png</a:t>
             </a:r>
@@ -7136,7 +7136,7 @@
                 <a:solidFill>
                   <a:srgbClr val="5F5D57"/>
                 </a:solidFill>
-                <a:latin typeface="Segoe UI"/>
+                <a:latin typeface="Segoe UI Semilight"/>
               </a:rPr>
               <a:t>(prompt in images/sources.prompt.txt)</a:t>
             </a:r>
@@ -7240,7 +7240,7 @@
                 <a:solidFill>
                   <a:srgbClr val="5F5D57"/>
                 </a:solidFill>
-                <a:latin typeface="Segoe UI"/>
+                <a:latin typeface="Segoe UI Semilight"/>
               </a:rPr>
               <a:t>picture to make by hand:</a:t>
             </a:r>
@@ -7252,7 +7252,7 @@
                 <a:solidFill>
                   <a:srgbClr val="5F5D57"/>
                 </a:solidFill>
-                <a:latin typeface="Segoe UI"/>
+                <a:latin typeface="Segoe UI Semilight"/>
               </a:rPr>
               <a:t>pipeline.png</a:t>
             </a:r>
@@ -7264,7 +7264,7 @@
                 <a:solidFill>
                   <a:srgbClr val="5F5D57"/>
                 </a:solidFill>
-                <a:latin typeface="Segoe UI"/>
+                <a:latin typeface="Segoe UI Semilight"/>
               </a:rPr>
               <a:t>(prompt in images/pipeline.prompt.txt)</a:t>
             </a:r>
@@ -7368,7 +7368,7 @@
                 <a:solidFill>
                   <a:srgbClr val="5F5D57"/>
                 </a:solidFill>
-                <a:latin typeface="Segoe UI"/>
+                <a:latin typeface="Segoe UI Semilight"/>
               </a:rPr>
               <a:t>picture to make by hand:</a:t>
             </a:r>
@@ -7380,7 +7380,7 @@
                 <a:solidFill>
                   <a:srgbClr val="5F5D57"/>
                 </a:solidFill>
-                <a:latin typeface="Segoe UI"/>
+                <a:latin typeface="Segoe UI Semilight"/>
               </a:rPr>
               <a:t>model.png</a:t>
             </a:r>
@@ -7392,7 +7392,7 @@
                 <a:solidFill>
                   <a:srgbClr val="5F5D57"/>
                 </a:solidFill>
-                <a:latin typeface="Segoe UI"/>
+                <a:latin typeface="Segoe UI Semilight"/>
               </a:rPr>
               <a:t>(prompt in images/model.prompt.txt)</a:t>
             </a:r>

</xml_diff>

<commit_message>
intent/kinneret-talk-deck: sources slide titled "Data Sources" (originator, via talk-helper)
Co-Authored-By: Claude Opus 5.5 <noreply@anthropic.com>
Claude-Session: https://claude.ai/code/session_0193nCV9LSRkjivJfTxWrDYe
</commit_message>
<xml_diff>
--- a/docs/talk/talk.pptx
+++ b/docs/talk/talk.pptx
@@ -7041,49 +7041,31 @@
         <p:nvPr/>
       </p:nvGrpSpPr>
       <p:grpSpPr/>
-      <p:sp>
-        <p:nvSpPr>
-          <p:cNvPr id="2" name="Rectangle 1"/>
-          <p:cNvSpPr/>
+      <p:pic>
+        <p:nvPicPr>
+          <p:cNvPr id="2" name="Picture 1" descr="sources.png"/>
+          <p:cNvPicPr>
+            <a:picLocks noChangeAspect="1"/>
+          </p:cNvPicPr>
           <p:nvPr/>
-        </p:nvSpPr>
+        </p:nvPicPr>
+        <p:blipFill>
+          <a:blip r:embed="rId2"/>
+          <a:srcRect l="1" r="1"/>
+          <a:stretch>
+            <a:fillRect/>
+          </a:stretch>
+        </p:blipFill>
         <p:spPr>
           <a:xfrm>
-            <a:off x="4480560" y="822960"/>
-            <a:ext cx="6949440" cy="5212080"/>
+            <a:off x="0" y="0"/>
+            <a:ext cx="12191695" cy="6858000"/>
           </a:xfrm>
           <a:prstGeom prst="rect">
             <a:avLst/>
           </a:prstGeom>
-          <a:solidFill>
-            <a:srgbClr val="E9E6DE"/>
-          </a:solidFill>
-          <a:ln>
-            <a:noFill/>
-          </a:ln>
         </p:spPr>
-        <p:style>
-          <a:lnRef idx="1">
-            <a:schemeClr val="accent1"/>
-          </a:lnRef>
-          <a:fillRef idx="3">
-            <a:schemeClr val="accent1"/>
-          </a:fillRef>
-          <a:effectRef idx="2">
-            <a:schemeClr val="accent1"/>
-          </a:effectRef>
-          <a:fontRef idx="minor">
-            <a:schemeClr val="lt1"/>
-          </a:fontRef>
-        </p:style>
-        <p:txBody>
-          <a:bodyPr rtlCol="0" anchor="ctr"/>
-          <a:lstStyle/>
-          <a:p>
-            <a:pPr algn="ctr"/>
-          </a:p>
-        </p:txBody>
-      </p:sp>
+      </p:pic>
       <p:sp>
         <p:nvSpPr>
           <p:cNvPr id="3" name="TextBox 2"/>
@@ -7092,8 +7074,8 @@
         </p:nvSpPr>
         <p:spPr>
           <a:xfrm>
-            <a:off x="4480560" y="822960"/>
-            <a:ext cx="6949440" cy="5212080"/>
+            <a:off x="548640" y="731520"/>
+            <a:ext cx="3657600" cy="5394960"/>
           </a:xfrm>
           <a:prstGeom prst="rect">
             <a:avLst/>
@@ -7106,39 +7088,15 @@
           </a:bodyPr>
           <a:lstStyle/>
           <a:p>
-            <a:pPr algn="ctr"/>
-            <a:r>
-              <a:rPr sz="2400" b="0">
+            <a:pPr algn="l"/>
+            <a:r>
+              <a:rPr sz="3600" b="0">
                 <a:solidFill>
-                  <a:srgbClr val="5F5D57"/>
+                  <a:srgbClr val="1D1D1B"/>
                 </a:solidFill>
-                <a:latin typeface="Segoe UI Semilight"/>
+                <a:latin typeface="Segoe UI Semibold"/>
               </a:rPr>
-              <a:t>picture to make by hand:</a:t>
-            </a:r>
-          </a:p>
-          <a:p>
-            <a:pPr algn="ctr"/>
-            <a:r>
-              <a:rPr sz="2400" b="0">
-                <a:solidFill>
-                  <a:srgbClr val="5F5D57"/>
-                </a:solidFill>
-                <a:latin typeface="Segoe UI Semilight"/>
-              </a:rPr>
-              <a:t>sources.png</a:t>
-            </a:r>
-          </a:p>
-          <a:p>
-            <a:pPr algn="ctr"/>
-            <a:r>
-              <a:rPr sz="2400" b="0">
-                <a:solidFill>
-                  <a:srgbClr val="5F5D57"/>
-                </a:solidFill>
-                <a:latin typeface="Segoe UI Semilight"/>
-              </a:rPr>
-              <a:t>(prompt in images/sources.prompt.txt)</a:t>
+              <a:t>Data Sources</a:t>
             </a:r>
           </a:p>
         </p:txBody>

</xml_diff>

<commit_message>
intent/kinneret-talk-deck: coverage slide - each record against time, why September 2012 (R39, D21, R32)
- Ledger: data.<series>.{start,end,gapN.*,switchN} for the lake level, five
  river stations, the weather and the radiation sensor, read from the silver
  files as they stood at the freeze. Gaps over 20 days from data.gold.start on;
  an end only for a record that stopped. Month-year displays throughout.
- charts.py: chart_data("coverage") and draw_coverage, one bar per record, the
  2012 line labelled "all sources line up". coverage_layer.png is the same
  drawing on a transparent background, for talk-helper's Gemini restyle.
- talk.md: the coverage slide after sources; the sources notes name the level
  site (Kinneret Drainage and Streams Authority) and Open-Meteo (R32).
- The freeze re-ran with --keep-models: 23 truth tests pass, stamped.

Co-Authored-By: Claude Opus 5.5 <noreply@anthropic.com>
Claude-Session: https://claude.ai/code/session_0193nCV9LSRkjivJfTxWrDYe
</commit_message>
<xml_diff>
--- a/docs/talk/talk.pptx
+++ b/docs/talk/talk.pptx
@@ -27,6 +27,7 @@
     <p:sldId id="275" r:id="rId27"/>
     <p:sldId id="276" r:id="rId28"/>
     <p:sldId id="277" r:id="rId29"/>
+    <p:sldId id="278" r:id="rId30"/>
   </p:sldIdLst>
   <p:sldSz cx="12191695" cy="6858000" type="screen4x3"/>
   <p:notesSz cx="6858000" cy="9144000"/>
@@ -598,12 +599,22 @@
           <a:lstStyle/>
           <a:p>
             <a:r>
-              <a:t>That's when I reached for the newest oldest trick in the book. You tell the AI: "You are a hydrology and meteorology specialist." It's role-play. The AI is not a hydrologist. But it reads your results differently. I called this persona Doctor Wade Storm.</a:t>
-            </a:r>
-          </a:p>
-          <a:p>
-            <a:r>
-              <a:t>Wade Storm noticed what I hadn't: every model that learned anything scored worst in 2023. Maybe not a model problem. Maybe a data problem. Even a great chef can't fix spoiled vegetables.</a:t>
+              <a:t>From here on, every number was measured on one data freeze, 11 October 2026. Only today's level comes from the app.</a:t>
+            </a:r>
+          </a:p>
+          <a:p>
+            <a:r>
+              <a:t>Eight models, each forecasting how many cubic metres the lake gains or loses each day, over the next week. The score is R squared: one is perfect, zero is no better than guessing the average.</a:t>
+            </a:r>
+          </a:p>
+          <a:p>
+            <a:r>
+              <a:t>Gradient boosting won. Every run, however I tweaked the data, it came back on top. Here it scores 0.73, trained and tested in 4 min.</a:t>
+            </a:r>
+          </a:p>
+          <a:p>
+            <a:r>
+              <a:t>So I tried to out-smart the AI at its own game, with a neural network. It scored -0.03. About zero, after 71 min of training and testing. A big defeat. So I decided to trust the AI's lead.</a:t>
             </a:r>
           </a:p>
         </p:txBody>
@@ -673,12 +684,12 @@
           <a:lstStyle/>
           <a:p>
             <a:r>
-              <a:t>Wade Storm was right. In 2023 the rain gauge at the lake went offline, and four small bugs in my pipeline quietly turned the missing readings into zero.</a:t>
-            </a:r>
-          </a:p>
-          <a:p>
-            <a:r>
-              <a:t>A whole year of rain became a dry year. No crash, no error. That's the scariest kind of bad data: the kind that looks fine.</a:t>
+              <a:t>That's when I reached for the newest oldest trick in the book. You tell the AI: "You are a hydrology and meteorology specialist." It's role-play. The AI is not a hydrologist. But it reads your results differently. I called this persona Doctor Wade Storm.</a:t>
+            </a:r>
+          </a:p>
+          <a:p>
+            <a:r>
+              <a:t>Wade Storm noticed what I hadn't: every model that learned anything scored worst in 2023. Maybe not a model problem. Maybe a data problem. Even a great chef can't fix spoiled vegetables.</a:t>
             </a:r>
           </a:p>
         </p:txBody>
@@ -748,17 +759,12 @@
           <a:lstStyle/>
           <a:p>
             <a:r>
-              <a:t>Here's the lesson I'd pass on. I didn't dive deep into every one of Wade Storm's pointers. I'm not a meteorologist; I rode the flow.</a:t>
-            </a:r>
-          </a:p>
-          <a:p>
-            <a:r>
-              <a:t>But you have to learn when to ride the agentic flow, letting the AI run the work step after step on its own, and when to take it into your own hands, or it drifts. What decided which changes stayed was measurement, not trust.</a:t>
-            </a:r>
-          </a:p>
-          <a:p>
-            <a:r>
-              <a:t>That's the centaur again: the machine explores, the person decides.</a:t>
+              <a:t>Wade Storm was right. In 2023 the rain gauge at the lake went offline, and four small bugs in my pipeline quietly turned the missing readings into zero.</a:t>
+            </a:r>
+          </a:p>
+          <a:p>
+            <a:r>
+              <a:t>A whole year of rain became a dry year. No crash, no error. That's the scariest kind of bad data: the kind that looks fine.</a:t>
             </a:r>
           </a:p>
         </p:txBody>
@@ -828,12 +834,17 @@
           <a:lstStyle/>
           <a:p>
             <a:r>
-              <a:t>So what came out of it? Start with a simpler question: tomorrow. Given today's real lake and the real weather, how well can we tell tomorrow's change?</a:t>
-            </a:r>
-          </a:p>
-          <a:p>
-            <a:r>
-              <a:t>The model scores 0.76. The usual change for the season scores 0.31, and "the lake stays the same" scores -0.02. Same days, same ruler, and again a best case.</a:t>
+              <a:t>Here's the lesson I'd pass on. I didn't dive deep into every one of Wade Storm's pointers. I'm not a meteorologist; I rode the flow.</a:t>
+            </a:r>
+          </a:p>
+          <a:p>
+            <a:r>
+              <a:t>But you have to learn when to ride the agentic flow, letting the AI run the work step after step on its own, and when to take it into your own hands, or it drifts. What decided which changes stayed was measurement, not trust.</a:t>
+            </a:r>
+          </a:p>
+          <a:p>
+            <a:r>
+              <a:t>That's the centaur again: the machine explores, the person decides.</a:t>
             </a:r>
           </a:p>
         </p:txBody>
@@ -903,17 +914,12 @@
           <a:lstStyle/>
           <a:p>
             <a:r>
-              <a:t>This is the history of that one-day score, and every step is labelled with what caused it.</a:t>
-            </a:r>
-          </a:p>
-          <a:p>
-            <a:r>
-              <a:t>It started at 0.694 (May 2026). The rain fix, and then six simple fixes Wade Storm suggested, took it to 0.758 (May 2026). One example: tell the model not just how much it rained, but how hard. A downpour runs off into the river; a drizzle soaks into the ground. I credit both, and every fix earned its place by measurement.</a:t>
-            </a:r>
-          </a:p>
-          <a:p>
-            <a:r>
-              <a:t>That was the biggest step by far, and it was both: a data fix and six model changes, together. After it the moves were small, and mostly data. On our freeze it scores 0.76.</a:t>
+              <a:t>So what came out of it? Start with a simpler question: tomorrow. Given today's real lake and the real weather, how well can we tell tomorrow's change?</a:t>
+            </a:r>
+          </a:p>
+          <a:p>
+            <a:r>
+              <a:t>The model scores 0.76. The usual change for the season scores 0.31, and "the lake stays the same" scores -0.02. Same days, same ruler, and again a best case.</a:t>
             </a:r>
           </a:p>
         </p:txBody>
@@ -983,17 +989,17 @@
           <a:lstStyle/>
           <a:p>
             <a:r>
-              <a:t>Now the week. Seven days ahead, starting from one real day and never peeking inside the week, the champion scores 0.73, as a best case. "The lake stays the same" scores -0.02. The margin is 0.75. Skill fades with distance, but a week holds.</a:t>
-            </a:r>
-          </a:p>
-          <a:p>
-            <a:r>
-              <a:t>One caveat for the technical people: this is daily volume change, not the level. The level moves slowly, so a score on level would look flattering.</a:t>
-            </a:r>
-          </a:p>
-          <a:p>
-            <a:r>
-              <a:t>And this week's forecast is in the app, for you to check against the lake.</a:t>
+              <a:t>This is the history of that one-day score, and every step is labelled with what caused it.</a:t>
+            </a:r>
+          </a:p>
+          <a:p>
+            <a:r>
+              <a:t>It started at 0.694 (May 2026). The rain fix, and then six simple fixes Wade Storm suggested, took it to 0.758 (May 2026). One example: tell the model not just how much it rained, but how hard. A downpour runs off into the river; a drizzle soaks into the ground. I credit both, and every fix earned its place by measurement.</a:t>
+            </a:r>
+          </a:p>
+          <a:p>
+            <a:r>
+              <a:t>That was the biggest step by far, and it was both: a data fix and six model changes, together. After it the moves were small, and mostly data. On our freeze it scores 0.76.</a:t>
             </a:r>
           </a:p>
         </p:txBody>
@@ -1063,17 +1069,17 @@
           <a:lstStyle/>
           <a:p>
             <a:r>
-              <a:t>Then Adnan pushed me further: what about the long term? I warned him I didn't expect good results, and I tried anyway.</a:t>
-            </a:r>
-          </a:p>
-          <a:p>
-            <a:r>
-              <a:t>These were shots in the dark, and I'll say so. The weather service's extended forecast, as an input, which turned out not to be available. A forecast driven by temperature alone. A set of regional climate models under two global-warming scenarios, which you can see on the app's climate page. And to rebuild the past back to 1960: the sun's radiation above the atmosphere, computed from astronomy, with the gap between day and night temperatures as a clue to cloud and rain.</a:t>
-            </a:r>
-          </a:p>
-          <a:p>
-            <a:r>
-              <a:t>Most missed. One partly hit: a simple soil-moisture bucket, the ground's memory of rain, gave some skill in winter, two to four weeks ahead.</a:t>
+              <a:t>Now the week. Seven days ahead, starting from one real day and never peeking inside the week, the champion scores 0.73, as a best case. "The lake stays the same" scores -0.02. The margin is 0.75. Skill fades with distance, but a week holds.</a:t>
+            </a:r>
+          </a:p>
+          <a:p>
+            <a:r>
+              <a:t>One caveat for the technical people: this is daily volume change, not the level. The level moves slowly, so a score on level would look flattering.</a:t>
+            </a:r>
+          </a:p>
+          <a:p>
+            <a:r>
+              <a:t>And this week's forecast is in the app, for you to check against the lake.</a:t>
             </a:r>
           </a:p>
         </p:txBody>
@@ -1143,22 +1149,17 @@
           <a:lstStyle/>
           <a:p>
             <a:r>
-              <a:t>Here is the frontier on one slide. Each panel is measured its own way.</a:t>
-            </a:r>
-          </a:p>
-          <a:p>
-            <a:r>
-              <a:t>One week: skilful. Two to four weeks: some skill in winter, thanks to that soil memory, and none in summer. Both are best cases.</a:t>
-            </a:r>
-          </a:p>
-          <a:p>
-            <a:r>
-              <a:t>On the right, the summer red line, with a seasonal method, not machine learning. Replayed for every crossing since 2008: with two weeks' to a month's warning, it misses the date by about 2 days. With two to three months, by about 22, and there the plain seasonal average does better, at 18. And 91 of its 753 forecasts never reached the line at all, every one issued two months or more ahead.</a:t>
-            </a:r>
-          </a:p>
-          <a:p>
-            <a:r>
-              <a:t>The frontier is where the data runs out.</a:t>
+              <a:t>Then Adnan pushed me further: what about the long term? I warned him I didn't expect good results, and I tried anyway.</a:t>
+            </a:r>
+          </a:p>
+          <a:p>
+            <a:r>
+              <a:t>These were shots in the dark, and I'll say so. The weather service's extended forecast, as an input, which turned out not to be available. A forecast driven by temperature alone. A set of regional climate models under two global-warming scenarios, which you can see on the app's climate page. And to rebuild the past back to 1960: the sun's radiation above the atmosphere, computed from astronomy, with the gap between day and night temperatures as a clue to cloud and rain.</a:t>
+            </a:r>
+          </a:p>
+          <a:p>
+            <a:r>
+              <a:t>Most missed. One partly hit: a simple soil-moisture bucket, the ground's memory of rain, gave some skill in winter, two to four weeks ahead.</a:t>
             </a:r>
           </a:p>
         </p:txBody>
@@ -1228,17 +1229,22 @@
           <a:lstStyle/>
           <a:p>
             <a:r>
-              <a:t>So what's missing? Three challenges, and each one applies to you.</a:t>
-            </a:r>
-          </a:p>
-          <a:p>
-            <a:r>
-              <a:t>First: bad data hides silently. A single dash in a weather file became a zero, and a whole year of rain disappeared.</a:t>
-            </a:r>
-          </a:p>
-          <a:p>
-            <a:r>
-              <a:t>This applies to you: when a number looks wrong, fix it at the source, where it entered. Don't patch it downstream.</a:t>
+              <a:t>Here is the frontier on one slide. Each panel is measured its own way.</a:t>
+            </a:r>
+          </a:p>
+          <a:p>
+            <a:r>
+              <a:t>One week: skilful. Two to four weeks: some skill in winter, thanks to that soil memory, and none in summer. Both are best cases.</a:t>
+            </a:r>
+          </a:p>
+          <a:p>
+            <a:r>
+              <a:t>On the right, the summer red line, with a seasonal method, not machine learning. Replayed for every crossing since 2008: with two weeks' to a month's warning, it misses the date by about 2 days. With two to three months, by about 22, and there the plain seasonal average does better, at 18. And 91 of its 753 forecasts never reached the line at all, every one issued two months or more ahead.</a:t>
+            </a:r>
+          </a:p>
+          <a:p>
+            <a:r>
+              <a:t>The frontier is where the data runs out.</a:t>
             </a:r>
           </a:p>
         </p:txBody>
@@ -1308,17 +1314,17 @@
           <a:lstStyle/>
           <a:p>
             <a:r>
-              <a:t>Second: records start, stop and change names. The Sede Nehemya station on the Jordan stopped in 2022, and the Yarmuk record ends in 2000. The station I first took as the lake's outflow, the Baptism Site, turned out to be on the lower Jordan, near the Dead Sea, not at the lake's outlet. The champion doesn't use it, but some of the other Olympics models do.</a:t>
-            </a:r>
-          </a:p>
-          <a:p>
-            <a:r>
-              <a:t>My model's table starts in September 2012, where the files I could download line up. Some of the weather stations go back further, so an earlier start may well be possible.</a:t>
-            </a:r>
-          </a:p>
-          <a:p>
-            <a:r>
-              <a:t>This applies to you: every data feed needs a backup source, and an alarm that rings when it goes quiet.</a:t>
+              <a:t>So what's missing? Three challenges, and each one applies to you.</a:t>
+            </a:r>
+          </a:p>
+          <a:p>
+            <a:r>
+              <a:t>First: bad data hides silently. A single dash in a weather file became a zero, and a whole year of rain disappeared.</a:t>
+            </a:r>
+          </a:p>
+          <a:p>
+            <a:r>
+              <a:t>This applies to you: when a number looks wrong, fix it at the source, where it entered. Don't patch it downstream.</a:t>
             </a:r>
           </a:p>
         </p:txBody>
@@ -1478,17 +1484,17 @@
           <a:lstStyle/>
           <a:p>
             <a:r>
-              <a:t>Third, and most critical: human consumption. Pumping and abstraction from the lake. That data wasn't available to me at all. The human hand on the water balance is invisible to my model.</a:t>
-            </a:r>
-          </a:p>
-          <a:p>
-            <a:r>
-              <a:t>This applies to you: if you hold data like this, share it.</a:t>
-            </a:r>
-          </a:p>
-          <a:p>
-            <a:r>
-              <a:t>And that's my first takeaway: more people handling data, in more advanced ways, and sharing it, is a much better starting point than any model.</a:t>
+              <a:t>Second: records start, stop and change names. The Sede Nehemya station on the Jordan stopped in September 2022, and the Yarmuk record ends in May 2000. The station I first took as the lake's outflow, the Baptism Site, turned out to be on the lower Jordan, near the Dead Sea, not at the lake's outlet. The champion doesn't use it, but some of the other Olympics models do.</a:t>
+            </a:r>
+          </a:p>
+          <a:p>
+            <a:r>
+              <a:t>My model's table starts in September 2012, where the files I could download line up. Some of the weather stations go back further, so an earlier start may well be possible.</a:t>
+            </a:r>
+          </a:p>
+          <a:p>
+            <a:r>
+              <a:t>This applies to you: every data feed needs a backup source, and an alarm that rings when it goes quiet.</a:t>
             </a:r>
           </a:p>
         </p:txBody>
@@ -1558,7 +1564,17 @@
           <a:lstStyle/>
           <a:p>
             <a:r>
-              <a:t>The second takeaway: build expertise. Dive deep into fields that aren't yours, and keep improving your own model: the human brain.</a:t>
+              <a:t>Third, and most critical: human consumption. Pumping and abstraction from the lake. That data wasn't available to me at all. The human hand on the water balance is invisible to my model.</a:t>
+            </a:r>
+          </a:p>
+          <a:p>
+            <a:r>
+              <a:t>This applies to you: if you hold data like this, share it.</a:t>
+            </a:r>
+          </a:p>
+          <a:p>
+            <a:r>
+              <a:t>And that's my first takeaway: more people handling data, in more advanced ways, and sharing it, is a much better starting point than any model.</a:t>
             </a:r>
           </a:p>
         </p:txBody>
@@ -1628,6 +1644,76 @@
           <a:lstStyle/>
           <a:p>
             <a:r>
+              <a:t>The second takeaway: build expertise. Dive deep into fields that aren't yours, and keep improving your own model: the human brain.</a:t>
+            </a:r>
+          </a:p>
+        </p:txBody>
+      </p:sp>
+      <p:sp>
+        <p:nvSpPr>
+          <p:cNvPr id="4" name="Slide Number Placeholder 3"/>
+          <p:cNvSpPr>
+            <a:spLocks noGrp="1"/>
+          </p:cNvSpPr>
+          <p:nvPr>
+            <p:ph type="sldNum" idx="5" sz="quarter"/>
+          </p:nvPr>
+        </p:nvSpPr>
+        <p:spPr/>
+      </p:sp>
+    </p:spTree>
+  </p:cSld>
+  <p:clrMapOvr>
+    <a:masterClrMapping/>
+  </p:clrMapOvr>
+</p:notes>
+</file>
+
+<file path=ppt/notesSlides/notesSlide23.xml><?xml version="1.0" encoding="utf-8"?>
+<p:notes xmlns:a="http://schemas.openxmlformats.org/drawingml/2006/main" xmlns:p="http://schemas.openxmlformats.org/presentationml/2006/main" xmlns:r="http://schemas.openxmlformats.org/officeDocument/2006/relationships">
+  <p:cSld>
+    <p:spTree>
+      <p:nvGrpSpPr>
+        <p:cNvPr id="1" name=""/>
+        <p:cNvGrpSpPr/>
+        <p:nvPr/>
+      </p:nvGrpSpPr>
+      <p:grpSpPr>
+        <a:xfrm>
+          <a:off x="0" y="0"/>
+          <a:ext cx="0" cy="0"/>
+          <a:chOff x="0" y="0"/>
+          <a:chExt cx="0" cy="0"/>
+        </a:xfrm>
+      </p:grpSpPr>
+      <p:sp>
+        <p:nvSpPr>
+          <p:cNvPr id="2" name="Slide Image Placeholder 1"/>
+          <p:cNvSpPr>
+            <a:spLocks noGrp="1"/>
+          </p:cNvSpPr>
+          <p:nvPr>
+            <p:ph type="sldImg" idx="2"/>
+          </p:nvPr>
+        </p:nvSpPr>
+        <p:spPr/>
+      </p:sp>
+      <p:sp>
+        <p:nvSpPr>
+          <p:cNvPr id="3" name="Notes Placeholder 2"/>
+          <p:cNvSpPr>
+            <a:spLocks noGrp="1"/>
+          </p:cNvSpPr>
+          <p:nvPr>
+            <p:ph type="body" idx="3" sz="quarter"/>
+          </p:nvPr>
+        </p:nvSpPr>
+        <p:spPr/>
+        <p:txBody>
+          <a:bodyPr/>
+          <a:lstStyle/>
+          <a:p>
+            <a:r>
               <a:t>Back to where we started. The lake, under the red line, waiting to see which winter comes.</a:t>
             </a:r>
           </a:p>
@@ -1968,7 +2054,7 @@
           <a:lstStyle/>
           <a:p>
             <a:r>
-              <a:t>Then the hunt for data. Three national authorities: the Water Authority for the lake's level, the Hydrological Service for the rivers, above all the Jordan, and the Meteorological Service for the rain, the heat, the wind and the sun.</a:t>
+              <a:t>Then the hunt for data. Three sources: the Kinneret Drainage and Streams Authority's site for the lake's level, the Hydrological Service for the rivers, above all the Jordan, and the Meteorological Service's records for the rain, the heat, the wind and the sun, kept current through Open-Meteo.</a:t>
             </a:r>
           </a:p>
           <a:p>
@@ -2043,17 +2129,7 @@
           <a:lstStyle/>
           <a:p>
             <a:r>
-              <a:t>You all know this picture better than I do. Raw water comes in, you treat it in stages, and clean water comes out.</a:t>
-            </a:r>
-          </a:p>
-          <a:p>
-            <a:r>
-              <a:t>Data works the same way. I already knew the stages from my first pipeline: collect the raw data, line it up in one table, clean it, then compute what matters. So building this one took hours, not weeks.</a:t>
-            </a:r>
-          </a:p>
-          <a:p>
-            <a:r>
-              <a:t>The days went into choosing what the model sees: which past days to show it, and where. I asked more than one AI about that.</a:t>
+              <a:t>Here is every record against time. The lake level goes back to September 1966, the Jordan at Obstacle Bridge to October 1970. Some records stopped, some paused, some changed source. The weather downloads start in June 2012. Only from September 2012 do all the sources line up, so that is where my model's table starts.</a:t>
             </a:r>
           </a:p>
         </p:txBody>
@@ -2123,12 +2199,17 @@
           <a:lstStyle/>
           <a:p>
             <a:r>
-              <a:t>Then the model. I searched the web for the best one, and the answer was XGBoost. So I asked Claude to build it. After a while I noticed it was building something else: gradient boosting. Many small decision trees, each one fixing the mistakes of the one before. Rather than argue, I said: let's race them.</a:t>
-            </a:r>
-          </a:p>
-          <a:p>
-            <a:r>
-              <a:t>In plain words, the model works in two steps, the way the water does. First rain and river: how much water the Jordan will carry in. Then the lake: how much it gains or loses each day, for each of the next seven days.</a:t>
+              <a:t>You all know this picture better than I do. Raw water comes in, you treat it in stages, and clean water comes out.</a:t>
+            </a:r>
+          </a:p>
+          <a:p>
+            <a:r>
+              <a:t>Data works the same way. I already knew the stages from my first pipeline: collect the raw data, line it up in one table, clean it, then compute what matters. So building this one took hours, not weeks.</a:t>
+            </a:r>
+          </a:p>
+          <a:p>
+            <a:r>
+              <a:t>The days went into choosing what the model sees: which past days to show it, and where. I asked more than one AI about that.</a:t>
             </a:r>
           </a:p>
         </p:txBody>
@@ -2198,22 +2279,12 @@
           <a:lstStyle/>
           <a:p>
             <a:r>
-              <a:t>From here on, every number was measured on one data freeze, 11 October 2026. Only today's level comes from the app.</a:t>
-            </a:r>
-          </a:p>
-          <a:p>
-            <a:r>
-              <a:t>Eight models, each forecasting how many cubic metres the lake gains or loses each day, over the next week. The score is R squared: one is perfect, zero is no better than guessing the average.</a:t>
-            </a:r>
-          </a:p>
-          <a:p>
-            <a:r>
-              <a:t>Gradient boosting won. Every run, however I tweaked the data, it came back on top. Here it scores 0.73, trained and tested in 4 min.</a:t>
-            </a:r>
-          </a:p>
-          <a:p>
-            <a:r>
-              <a:t>So I tried to out-smart the AI at its own game, with a neural network. It scored -0.03. About zero, after 71 min of training and testing. A big defeat. So I decided to trust the AI's lead.</a:t>
+              <a:t>Then the model. I searched the web for the best one, and the answer was XGBoost. So I asked Claude to build it. After a while I noticed it was building something else: gradient boosting. Many small decision trees, each one fixing the mistakes of the one before. Rather than argue, I said: let's race them.</a:t>
+            </a:r>
+          </a:p>
+          <a:p>
+            <a:r>
+              <a:t>In plain words, the model works in two steps, the way the water does. First rain and river: how much water the Jordan will carry in. Then the lake: how much it gains or loses each day, for each of the next seven days.</a:t>
             </a:r>
           </a:p>
         </p:txBody>
@@ -5347,6 +5418,56 @@
         <p:nvPr/>
       </p:nvGrpSpPr>
       <p:grpSpPr/>
+      <p:pic>
+        <p:nvPicPr>
+          <p:cNvPr id="2" name="Picture 1" descr="olympics.png"/>
+          <p:cNvPicPr>
+            <a:picLocks noChangeAspect="1"/>
+          </p:cNvPicPr>
+          <p:nvPr/>
+        </p:nvPicPr>
+        <p:blipFill>
+          <a:blip r:embed="rId2"/>
+          <a:stretch>
+            <a:fillRect/>
+          </a:stretch>
+        </p:blipFill>
+        <p:spPr>
+          <a:xfrm>
+            <a:off x="0" y="227079"/>
+            <a:ext cx="12191695" cy="6403841"/>
+          </a:xfrm>
+          <a:prstGeom prst="rect">
+            <a:avLst/>
+          </a:prstGeom>
+        </p:spPr>
+      </p:pic>
+    </p:spTree>
+  </p:cSld>
+  <p:clrMapOvr>
+    <a:masterClrMapping/>
+  </p:clrMapOvr>
+</p:sld>
+</file>
+
+<file path=ppt/slides/slide11.xml><?xml version="1.0" encoding="utf-8"?>
+<p:sld xmlns:a="http://schemas.openxmlformats.org/drawingml/2006/main" xmlns:p="http://schemas.openxmlformats.org/presentationml/2006/main" xmlns:r="http://schemas.openxmlformats.org/officeDocument/2006/relationships">
+  <p:cSld>
+    <p:bg>
+      <p:bgPr>
+        <a:solidFill>
+          <a:srgbClr val="FBFAF7"/>
+        </a:solidFill>
+        <a:effectLst/>
+      </p:bgPr>
+    </p:bg>
+    <p:spTree>
+      <p:nvGrpSpPr>
+        <p:cNvPr id="1" name=""/>
+        <p:cNvGrpSpPr/>
+        <p:nvPr/>
+      </p:nvGrpSpPr>
+      <p:grpSpPr/>
       <p:sp>
         <p:nvSpPr>
           <p:cNvPr id="2" name="Rectangle 1"/>
@@ -5492,7 +5613,7 @@
 </p:sld>
 </file>
 
-<file path=ppt/slides/slide11.xml><?xml version="1.0" encoding="utf-8"?>
+<file path=ppt/slides/slide12.xml><?xml version="1.0" encoding="utf-8"?>
 <p:sld xmlns:a="http://schemas.openxmlformats.org/drawingml/2006/main" xmlns:p="http://schemas.openxmlformats.org/presentationml/2006/main" xmlns:r="http://schemas.openxmlformats.org/officeDocument/2006/relationships">
   <p:cSld>
     <p:bg>
@@ -5620,7 +5741,7 @@
 </p:sld>
 </file>
 
-<file path=ppt/slides/slide12.xml><?xml version="1.0" encoding="utf-8"?>
+<file path=ppt/slides/slide13.xml><?xml version="1.0" encoding="utf-8"?>
 <p:sld xmlns:a="http://schemas.openxmlformats.org/drawingml/2006/main" xmlns:p="http://schemas.openxmlformats.org/presentationml/2006/main" xmlns:r="http://schemas.openxmlformats.org/officeDocument/2006/relationships">
   <p:cSld>
     <p:bg>
@@ -5783,7 +5904,7 @@
 </p:sld>
 </file>
 
-<file path=ppt/slides/slide13.xml><?xml version="1.0" encoding="utf-8"?>
+<file path=ppt/slides/slide14.xml><?xml version="1.0" encoding="utf-8"?>
 <p:sld xmlns:a="http://schemas.openxmlformats.org/drawingml/2006/main" xmlns:p="http://schemas.openxmlformats.org/presentationml/2006/main" xmlns:r="http://schemas.openxmlformats.org/officeDocument/2006/relationships">
   <p:cSld>
     <p:bg>
@@ -5833,7 +5954,7 @@
 </p:sld>
 </file>
 
-<file path=ppt/slides/slide14.xml><?xml version="1.0" encoding="utf-8"?>
+<file path=ppt/slides/slide15.xml><?xml version="1.0" encoding="utf-8"?>
 <p:sld xmlns:a="http://schemas.openxmlformats.org/drawingml/2006/main" xmlns:p="http://schemas.openxmlformats.org/presentationml/2006/main" xmlns:r="http://schemas.openxmlformats.org/officeDocument/2006/relationships">
   <p:cSld>
     <p:bg>
@@ -5883,7 +6004,7 @@
 </p:sld>
 </file>
 
-<file path=ppt/slides/slide15.xml><?xml version="1.0" encoding="utf-8"?>
+<file path=ppt/slides/slide16.xml><?xml version="1.0" encoding="utf-8"?>
 <p:sld xmlns:a="http://schemas.openxmlformats.org/drawingml/2006/main" xmlns:p="http://schemas.openxmlformats.org/presentationml/2006/main" xmlns:r="http://schemas.openxmlformats.org/officeDocument/2006/relationships">
   <p:cSld>
     <p:bg>
@@ -5933,7 +6054,7 @@
 </p:sld>
 </file>
 
-<file path=ppt/slides/slide16.xml><?xml version="1.0" encoding="utf-8"?>
+<file path=ppt/slides/slide17.xml><?xml version="1.0" encoding="utf-8"?>
 <p:sld xmlns:a="http://schemas.openxmlformats.org/drawingml/2006/main" xmlns:p="http://schemas.openxmlformats.org/presentationml/2006/main" xmlns:r="http://schemas.openxmlformats.org/officeDocument/2006/relationships">
   <p:cSld>
     <p:bg>
@@ -6061,7 +6182,7 @@
 </p:sld>
 </file>
 
-<file path=ppt/slides/slide17.xml><?xml version="1.0" encoding="utf-8"?>
+<file path=ppt/slides/slide18.xml><?xml version="1.0" encoding="utf-8"?>
 <p:sld xmlns:a="http://schemas.openxmlformats.org/drawingml/2006/main" xmlns:p="http://schemas.openxmlformats.org/presentationml/2006/main" xmlns:r="http://schemas.openxmlformats.org/officeDocument/2006/relationships">
   <p:cSld>
     <p:bg>
@@ -6111,7 +6232,7 @@
 </p:sld>
 </file>
 
-<file path=ppt/slides/slide18.xml><?xml version="1.0" encoding="utf-8"?>
+<file path=ppt/slides/slide19.xml><?xml version="1.0" encoding="utf-8"?>
 <p:sld xmlns:a="http://schemas.openxmlformats.org/drawingml/2006/main" xmlns:p="http://schemas.openxmlformats.org/presentationml/2006/main" xmlns:r="http://schemas.openxmlformats.org/officeDocument/2006/relationships">
   <p:cSld>
     <p:bg>
@@ -6227,134 +6348,6 @@
                 <a:latin typeface="Segoe UI Semilight"/>
               </a:rPr>
               <a:t>(prompt in images/silent.prompt.txt)</a:t>
-            </a:r>
-          </a:p>
-        </p:txBody>
-      </p:sp>
-    </p:spTree>
-  </p:cSld>
-  <p:clrMapOvr>
-    <a:masterClrMapping/>
-  </p:clrMapOvr>
-</p:sld>
-</file>
-
-<file path=ppt/slides/slide19.xml><?xml version="1.0" encoding="utf-8"?>
-<p:sld xmlns:a="http://schemas.openxmlformats.org/drawingml/2006/main" xmlns:p="http://schemas.openxmlformats.org/presentationml/2006/main" xmlns:r="http://schemas.openxmlformats.org/officeDocument/2006/relationships">
-  <p:cSld>
-    <p:bg>
-      <p:bgPr>
-        <a:solidFill>
-          <a:srgbClr val="FBFAF7"/>
-        </a:solidFill>
-        <a:effectLst/>
-      </p:bgPr>
-    </p:bg>
-    <p:spTree>
-      <p:nvGrpSpPr>
-        <p:cNvPr id="1" name=""/>
-        <p:cNvGrpSpPr/>
-        <p:nvPr/>
-      </p:nvGrpSpPr>
-      <p:grpSpPr/>
-      <p:sp>
-        <p:nvSpPr>
-          <p:cNvPr id="2" name="Rectangle 1"/>
-          <p:cNvSpPr/>
-          <p:nvPr/>
-        </p:nvSpPr>
-        <p:spPr>
-          <a:xfrm>
-            <a:off x="4480560" y="822960"/>
-            <a:ext cx="6949440" cy="5212080"/>
-          </a:xfrm>
-          <a:prstGeom prst="rect">
-            <a:avLst/>
-          </a:prstGeom>
-          <a:solidFill>
-            <a:srgbClr val="E9E6DE"/>
-          </a:solidFill>
-          <a:ln>
-            <a:noFill/>
-          </a:ln>
-        </p:spPr>
-        <p:style>
-          <a:lnRef idx="1">
-            <a:schemeClr val="accent1"/>
-          </a:lnRef>
-          <a:fillRef idx="3">
-            <a:schemeClr val="accent1"/>
-          </a:fillRef>
-          <a:effectRef idx="2">
-            <a:schemeClr val="accent1"/>
-          </a:effectRef>
-          <a:fontRef idx="minor">
-            <a:schemeClr val="lt1"/>
-          </a:fontRef>
-        </p:style>
-        <p:txBody>
-          <a:bodyPr rtlCol="0" anchor="ctr"/>
-          <a:lstStyle/>
-          <a:p>
-            <a:pPr algn="ctr"/>
-          </a:p>
-        </p:txBody>
-      </p:sp>
-      <p:sp>
-        <p:nvSpPr>
-          <p:cNvPr id="3" name="TextBox 2"/>
-          <p:cNvSpPr txBox="1"/>
-          <p:nvPr/>
-        </p:nvSpPr>
-        <p:spPr>
-          <a:xfrm>
-            <a:off x="4480560" y="822960"/>
-            <a:ext cx="6949440" cy="5212080"/>
-          </a:xfrm>
-          <a:prstGeom prst="rect">
-            <a:avLst/>
-          </a:prstGeom>
-          <a:noFill/>
-        </p:spPr>
-        <p:txBody>
-          <a:bodyPr wrap="square" anchor="ctr">
-            <a:spAutoFit/>
-          </a:bodyPr>
-          <a:lstStyle/>
-          <a:p>
-            <a:pPr algn="ctr"/>
-            <a:r>
-              <a:rPr sz="2400" b="0">
-                <a:solidFill>
-                  <a:srgbClr val="5F5D57"/>
-                </a:solidFill>
-                <a:latin typeface="Segoe UI Semilight"/>
-              </a:rPr>
-              <a:t>picture to make by hand:</a:t>
-            </a:r>
-          </a:p>
-          <a:p>
-            <a:pPr algn="ctr"/>
-            <a:r>
-              <a:rPr sz="2400" b="0">
-                <a:solidFill>
-                  <a:srgbClr val="5F5D57"/>
-                </a:solidFill>
-                <a:latin typeface="Segoe UI Semilight"/>
-              </a:rPr>
-              <a:t>sensors.png</a:t>
-            </a:r>
-          </a:p>
-          <a:p>
-            <a:pPr algn="ctr"/>
-            <a:r>
-              <a:rPr sz="2400" b="0">
-                <a:solidFill>
-                  <a:srgbClr val="5F5D57"/>
-                </a:solidFill>
-                <a:latin typeface="Segoe UI Semilight"/>
-              </a:rPr>
-              <a:t>(prompt in images/sensors.prompt.txt)</a:t>
             </a:r>
           </a:p>
         </p:txBody>
@@ -6520,7 +6513,7 @@
                 </a:solidFill>
                 <a:latin typeface="Segoe UI Semilight"/>
               </a:rPr>
-              <a:t>share.png</a:t>
+              <a:t>sensors.png</a:t>
             </a:r>
           </a:p>
           <a:p>
@@ -6532,7 +6525,7 @@
                 </a:solidFill>
                 <a:latin typeface="Segoe UI Semilight"/>
               </a:rPr>
-              <a:t>(prompt in images/share.prompt.txt)</a:t>
+              <a:t>(prompt in images/sensors.prompt.txt)</a:t>
             </a:r>
           </a:p>
         </p:txBody>
@@ -6648,7 +6641,7 @@
                 </a:solidFill>
                 <a:latin typeface="Segoe UI Semilight"/>
               </a:rPr>
-              <a:t>brain.png</a:t>
+              <a:t>share.png</a:t>
             </a:r>
           </a:p>
           <a:p>
@@ -6660,7 +6653,7 @@
                 </a:solidFill>
                 <a:latin typeface="Segoe UI Semilight"/>
               </a:rPr>
-              <a:t>(prompt in images/brain.prompt.txt)</a:t>
+              <a:t>(prompt in images/share.prompt.txt)</a:t>
             </a:r>
           </a:p>
         </p:txBody>
@@ -6674,6 +6667,134 @@
 </file>
 
 <file path=ppt/slides/slide22.xml><?xml version="1.0" encoding="utf-8"?>
+<p:sld xmlns:a="http://schemas.openxmlformats.org/drawingml/2006/main" xmlns:p="http://schemas.openxmlformats.org/presentationml/2006/main" xmlns:r="http://schemas.openxmlformats.org/officeDocument/2006/relationships">
+  <p:cSld>
+    <p:bg>
+      <p:bgPr>
+        <a:solidFill>
+          <a:srgbClr val="FBFAF7"/>
+        </a:solidFill>
+        <a:effectLst/>
+      </p:bgPr>
+    </p:bg>
+    <p:spTree>
+      <p:nvGrpSpPr>
+        <p:cNvPr id="1" name=""/>
+        <p:cNvGrpSpPr/>
+        <p:nvPr/>
+      </p:nvGrpSpPr>
+      <p:grpSpPr/>
+      <p:sp>
+        <p:nvSpPr>
+          <p:cNvPr id="2" name="Rectangle 1"/>
+          <p:cNvSpPr/>
+          <p:nvPr/>
+        </p:nvSpPr>
+        <p:spPr>
+          <a:xfrm>
+            <a:off x="4480560" y="822960"/>
+            <a:ext cx="6949440" cy="5212080"/>
+          </a:xfrm>
+          <a:prstGeom prst="rect">
+            <a:avLst/>
+          </a:prstGeom>
+          <a:solidFill>
+            <a:srgbClr val="E9E6DE"/>
+          </a:solidFill>
+          <a:ln>
+            <a:noFill/>
+          </a:ln>
+        </p:spPr>
+        <p:style>
+          <a:lnRef idx="1">
+            <a:schemeClr val="accent1"/>
+          </a:lnRef>
+          <a:fillRef idx="3">
+            <a:schemeClr val="accent1"/>
+          </a:fillRef>
+          <a:effectRef idx="2">
+            <a:schemeClr val="accent1"/>
+          </a:effectRef>
+          <a:fontRef idx="minor">
+            <a:schemeClr val="lt1"/>
+          </a:fontRef>
+        </p:style>
+        <p:txBody>
+          <a:bodyPr rtlCol="0" anchor="ctr"/>
+          <a:lstStyle/>
+          <a:p>
+            <a:pPr algn="ctr"/>
+          </a:p>
+        </p:txBody>
+      </p:sp>
+      <p:sp>
+        <p:nvSpPr>
+          <p:cNvPr id="3" name="TextBox 2"/>
+          <p:cNvSpPr txBox="1"/>
+          <p:nvPr/>
+        </p:nvSpPr>
+        <p:spPr>
+          <a:xfrm>
+            <a:off x="4480560" y="822960"/>
+            <a:ext cx="6949440" cy="5212080"/>
+          </a:xfrm>
+          <a:prstGeom prst="rect">
+            <a:avLst/>
+          </a:prstGeom>
+          <a:noFill/>
+        </p:spPr>
+        <p:txBody>
+          <a:bodyPr wrap="square" anchor="ctr">
+            <a:spAutoFit/>
+          </a:bodyPr>
+          <a:lstStyle/>
+          <a:p>
+            <a:pPr algn="ctr"/>
+            <a:r>
+              <a:rPr sz="2400" b="0">
+                <a:solidFill>
+                  <a:srgbClr val="5F5D57"/>
+                </a:solidFill>
+                <a:latin typeface="Segoe UI Semilight"/>
+              </a:rPr>
+              <a:t>picture to make by hand:</a:t>
+            </a:r>
+          </a:p>
+          <a:p>
+            <a:pPr algn="ctr"/>
+            <a:r>
+              <a:rPr sz="2400" b="0">
+                <a:solidFill>
+                  <a:srgbClr val="5F5D57"/>
+                </a:solidFill>
+                <a:latin typeface="Segoe UI Semilight"/>
+              </a:rPr>
+              <a:t>brain.png</a:t>
+            </a:r>
+          </a:p>
+          <a:p>
+            <a:pPr algn="ctr"/>
+            <a:r>
+              <a:rPr sz="2400" b="0">
+                <a:solidFill>
+                  <a:srgbClr val="5F5D57"/>
+                </a:solidFill>
+                <a:latin typeface="Segoe UI Semilight"/>
+              </a:rPr>
+              <a:t>(prompt in images/brain.prompt.txt)</a:t>
+            </a:r>
+          </a:p>
+        </p:txBody>
+      </p:sp>
+    </p:spTree>
+  </p:cSld>
+  <p:clrMapOvr>
+    <a:masterClrMapping/>
+  </p:clrMapOvr>
+</p:sld>
+</file>
+
+<file path=ppt/slides/slide23.xml><?xml version="1.0" encoding="utf-8"?>
 <p:sld xmlns:a="http://schemas.openxmlformats.org/drawingml/2006/main" xmlns:p="http://schemas.openxmlformats.org/presentationml/2006/main" xmlns:r="http://schemas.openxmlformats.org/officeDocument/2006/relationships">
   <p:cSld>
     <p:bg>
@@ -7127,6 +7248,56 @@
         <p:nvPr/>
       </p:nvGrpSpPr>
       <p:grpSpPr/>
+      <p:pic>
+        <p:nvPicPr>
+          <p:cNvPr id="2" name="Picture 1" descr="coverage.png"/>
+          <p:cNvPicPr>
+            <a:picLocks noChangeAspect="1"/>
+          </p:cNvPicPr>
+          <p:nvPr/>
+        </p:nvPicPr>
+        <p:blipFill>
+          <a:blip r:embed="rId2"/>
+          <a:stretch>
+            <a:fillRect/>
+          </a:stretch>
+        </p:blipFill>
+        <p:spPr>
+          <a:xfrm>
+            <a:off x="0" y="227079"/>
+            <a:ext cx="12191695" cy="6403841"/>
+          </a:xfrm>
+          <a:prstGeom prst="rect">
+            <a:avLst/>
+          </a:prstGeom>
+        </p:spPr>
+      </p:pic>
+    </p:spTree>
+  </p:cSld>
+  <p:clrMapOvr>
+    <a:masterClrMapping/>
+  </p:clrMapOvr>
+</p:sld>
+</file>
+
+<file path=ppt/slides/slide8.xml><?xml version="1.0" encoding="utf-8"?>
+<p:sld xmlns:a="http://schemas.openxmlformats.org/drawingml/2006/main" xmlns:p="http://schemas.openxmlformats.org/presentationml/2006/main" xmlns:r="http://schemas.openxmlformats.org/officeDocument/2006/relationships">
+  <p:cSld>
+    <p:bg>
+      <p:bgPr>
+        <a:solidFill>
+          <a:srgbClr val="FBFAF7"/>
+        </a:solidFill>
+        <a:effectLst/>
+      </p:bgPr>
+    </p:bg>
+    <p:spTree>
+      <p:nvGrpSpPr>
+        <p:cNvPr id="1" name=""/>
+        <p:cNvGrpSpPr/>
+        <p:nvPr/>
+      </p:nvGrpSpPr>
+      <p:grpSpPr/>
       <p:sp>
         <p:nvSpPr>
           <p:cNvPr id="2" name="Rectangle 1"/>
@@ -7237,7 +7408,7 @@
 </p:sld>
 </file>
 
-<file path=ppt/slides/slide8.xml><?xml version="1.0" encoding="utf-8"?>
+<file path=ppt/slides/slide9.xml><?xml version="1.0" encoding="utf-8"?>
 <p:sld xmlns:a="http://schemas.openxmlformats.org/drawingml/2006/main" xmlns:p="http://schemas.openxmlformats.org/presentationml/2006/main" xmlns:r="http://schemas.openxmlformats.org/officeDocument/2006/relationships">
   <p:cSld>
     <p:bg>
@@ -7357,56 +7528,6 @@
           </a:p>
         </p:txBody>
       </p:sp>
-    </p:spTree>
-  </p:cSld>
-  <p:clrMapOvr>
-    <a:masterClrMapping/>
-  </p:clrMapOvr>
-</p:sld>
-</file>
-
-<file path=ppt/slides/slide9.xml><?xml version="1.0" encoding="utf-8"?>
-<p:sld xmlns:a="http://schemas.openxmlformats.org/drawingml/2006/main" xmlns:p="http://schemas.openxmlformats.org/presentationml/2006/main" xmlns:r="http://schemas.openxmlformats.org/officeDocument/2006/relationships">
-  <p:cSld>
-    <p:bg>
-      <p:bgPr>
-        <a:solidFill>
-          <a:srgbClr val="FBFAF7"/>
-        </a:solidFill>
-        <a:effectLst/>
-      </p:bgPr>
-    </p:bg>
-    <p:spTree>
-      <p:nvGrpSpPr>
-        <p:cNvPr id="1" name=""/>
-        <p:cNvGrpSpPr/>
-        <p:nvPr/>
-      </p:nvGrpSpPr>
-      <p:grpSpPr/>
-      <p:pic>
-        <p:nvPicPr>
-          <p:cNvPr id="2" name="Picture 1" descr="olympics.png"/>
-          <p:cNvPicPr>
-            <a:picLocks noChangeAspect="1"/>
-          </p:cNvPicPr>
-          <p:nvPr/>
-        </p:nvPicPr>
-        <p:blipFill>
-          <a:blip r:embed="rId2"/>
-          <a:stretch>
-            <a:fillRect/>
-          </a:stretch>
-        </p:blipFill>
-        <p:spPr>
-          <a:xfrm>
-            <a:off x="0" y="227079"/>
-            <a:ext cx="12191695" cy="6403841"/>
-          </a:xfrm>
-          <a:prstGeom prst="rect">
-            <a:avLst/>
-          </a:prstGeom>
-        </p:spPr>
-      </p:pic>
     </p:spTree>
   </p:cSld>
   <p:clrMapOvr>

</xml_diff>